<commit_message>
Updated README.md with more in-depth description and instructions
</commit_message>
<xml_diff>
--- a/Project 1 - bankingAPP/BankingApp Presentation.pptx
+++ b/Project 1 - bankingAPP/BankingApp Presentation.pptx
@@ -122,7 +122,7 @@
 <file path=ppt/revisionInfo.xml><?xml version="1.0" encoding="utf-8"?>
 <p1510:revInfo xmlns:a="http://schemas.openxmlformats.org/drawingml/2006/main" xmlns:r="http://schemas.openxmlformats.org/officeDocument/2006/relationships" xmlns:p1510="http://schemas.microsoft.com/office/powerpoint/2015/10/main">
   <p1510:revLst>
-    <p1510:client id="{2ECACCFA-BF28-407F-9FAD-12DF83090C10}" v="13" dt="2026-09-24T04:21:08.757"/>
+    <p1510:client id="{2ECACCFA-BF28-407F-9FAD-12DF83090C10}" v="31" dt="2026-09-25T03:14:57.238"/>
   </p1510:revLst>
 </p1510:revInfo>
 </file>
@@ -132,18 +132,33 @@
   <pc:docChgLst>
     <pc:chgData name="Khalon Rodney" userId="4f27803adad79339" providerId="LiveId" clId="{A02A73CA-AD03-4032-B1B6-1CECF09FFE76}"/>
     <pc:docChg chg="undo custSel addSld modSld">
-      <pc:chgData name="Khalon Rodney" userId="4f27803adad79339" providerId="LiveId" clId="{A02A73CA-AD03-4032-B1B6-1CECF09FFE76}" dt="2026-09-24T04:21:11.208" v="1741" actId="20577"/>
+      <pc:chgData name="Khalon Rodney" userId="4f27803adad79339" providerId="LiveId" clId="{A02A73CA-AD03-4032-B1B6-1CECF09FFE76}" dt="2026-09-25T03:15:13.700" v="1785" actId="20577"/>
       <pc:docMkLst>
         <pc:docMk/>
       </pc:docMkLst>
+      <pc:sldChg chg="modSp">
+        <pc:chgData name="Khalon Rodney" userId="4f27803adad79339" providerId="LiveId" clId="{A02A73CA-AD03-4032-B1B6-1CECF09FFE76}" dt="2026-09-25T03:14:57.238" v="1765" actId="20577"/>
+        <pc:sldMkLst>
+          <pc:docMk/>
+          <pc:sldMk cId="276192844" sldId="256"/>
+        </pc:sldMkLst>
+        <pc:spChg chg="mod">
+          <ac:chgData name="Khalon Rodney" userId="4f27803adad79339" providerId="LiveId" clId="{A02A73CA-AD03-4032-B1B6-1CECF09FFE76}" dt="2026-09-25T03:14:57.238" v="1765" actId="20577"/>
+          <ac:spMkLst>
+            <pc:docMk/>
+            <pc:sldMk cId="276192844" sldId="256"/>
+            <ac:spMk id="2" creationId="{6020781B-E6B8-ECD9-66E9-0DA0096B6949}"/>
+          </ac:spMkLst>
+        </pc:spChg>
+      </pc:sldChg>
       <pc:sldChg chg="addSp delSp modSp mod setBg">
-        <pc:chgData name="Khalon Rodney" userId="4f27803adad79339" providerId="LiveId" clId="{A02A73CA-AD03-4032-B1B6-1CECF09FFE76}" dt="2026-09-23T22:02:39.496" v="319" actId="14100"/>
+        <pc:chgData name="Khalon Rodney" userId="4f27803adad79339" providerId="LiveId" clId="{A02A73CA-AD03-4032-B1B6-1CECF09FFE76}" dt="2026-09-25T03:15:13.700" v="1785" actId="20577"/>
         <pc:sldMkLst>
           <pc:docMk/>
           <pc:sldMk cId="1931892355" sldId="257"/>
         </pc:sldMkLst>
         <pc:spChg chg="mod">
-          <ac:chgData name="Khalon Rodney" userId="4f27803adad79339" providerId="LiveId" clId="{A02A73CA-AD03-4032-B1B6-1CECF09FFE76}" dt="2026-09-23T22:01:00.897" v="294" actId="26606"/>
+          <ac:chgData name="Khalon Rodney" userId="4f27803adad79339" providerId="LiveId" clId="{A02A73CA-AD03-4032-B1B6-1CECF09FFE76}" dt="2026-09-25T03:14:25.906" v="1743" actId="26606"/>
           <ac:spMkLst>
             <pc:docMk/>
             <pc:sldMk cId="1931892355" sldId="257"/>
@@ -151,7 +166,7 @@
           </ac:spMkLst>
         </pc:spChg>
         <pc:spChg chg="mod">
-          <ac:chgData name="Khalon Rodney" userId="4f27803adad79339" providerId="LiveId" clId="{A02A73CA-AD03-4032-B1B6-1CECF09FFE76}" dt="2026-09-23T22:02:39.496" v="319" actId="14100"/>
+          <ac:chgData name="Khalon Rodney" userId="4f27803adad79339" providerId="LiveId" clId="{A02A73CA-AD03-4032-B1B6-1CECF09FFE76}" dt="2026-09-25T03:15:13.700" v="1785" actId="20577"/>
           <ac:spMkLst>
             <pc:docMk/>
             <pc:sldMk cId="1931892355" sldId="257"/>
@@ -159,147 +174,51 @@
           </ac:spMkLst>
         </pc:spChg>
         <pc:spChg chg="add del">
-          <ac:chgData name="Khalon Rodney" userId="4f27803adad79339" providerId="LiveId" clId="{A02A73CA-AD03-4032-B1B6-1CECF09FFE76}" dt="2026-09-23T22:00:47.890" v="283" actId="26606"/>
-          <ac:spMkLst>
-            <pc:docMk/>
-            <pc:sldMk cId="1931892355" sldId="257"/>
-            <ac:spMk id="10" creationId="{2B97F24A-32CE-4C1C-A50D-3016B394DCFB}"/>
-          </ac:spMkLst>
-        </pc:spChg>
-        <pc:spChg chg="add del">
-          <ac:chgData name="Khalon Rodney" userId="4f27803adad79339" providerId="LiveId" clId="{A02A73CA-AD03-4032-B1B6-1CECF09FFE76}" dt="2026-09-23T22:00:47.890" v="283" actId="26606"/>
-          <ac:spMkLst>
-            <pc:docMk/>
-            <pc:sldMk cId="1931892355" sldId="257"/>
-            <ac:spMk id="12" creationId="{CD8B4F24-440B-49E9-B85D-733523DC064B}"/>
-          </ac:spMkLst>
-        </pc:spChg>
-        <pc:spChg chg="add del">
-          <ac:chgData name="Khalon Rodney" userId="4f27803adad79339" providerId="LiveId" clId="{A02A73CA-AD03-4032-B1B6-1CECF09FFE76}" dt="2026-09-23T22:00:49.532" v="285" actId="26606"/>
-          <ac:spMkLst>
-            <pc:docMk/>
-            <pc:sldMk cId="1931892355" sldId="257"/>
-            <ac:spMk id="14" creationId="{E659831F-0D9A-4C63-9EBB-8435B85A440F}"/>
-          </ac:spMkLst>
-        </pc:spChg>
-        <pc:spChg chg="add del">
-          <ac:chgData name="Khalon Rodney" userId="4f27803adad79339" providerId="LiveId" clId="{A02A73CA-AD03-4032-B1B6-1CECF09FFE76}" dt="2026-09-23T22:00:49.532" v="285" actId="26606"/>
-          <ac:spMkLst>
-            <pc:docMk/>
-            <pc:sldMk cId="1931892355" sldId="257"/>
-            <ac:spMk id="15" creationId="{058A14AF-9FB5-4CC7-BA35-E8E85D3EDF0E}"/>
-          </ac:spMkLst>
-        </pc:spChg>
-        <pc:spChg chg="add del">
-          <ac:chgData name="Khalon Rodney" userId="4f27803adad79339" providerId="LiveId" clId="{A02A73CA-AD03-4032-B1B6-1CECF09FFE76}" dt="2026-09-23T22:00:49.532" v="285" actId="26606"/>
-          <ac:spMkLst>
-            <pc:docMk/>
-            <pc:sldMk cId="1931892355" sldId="257"/>
-            <ac:spMk id="16" creationId="{E6995CE5-F890-4ABA-82A2-26507CE8D2A3}"/>
-          </ac:spMkLst>
-        </pc:spChg>
-        <pc:spChg chg="add del">
-          <ac:chgData name="Khalon Rodney" userId="4f27803adad79339" providerId="LiveId" clId="{A02A73CA-AD03-4032-B1B6-1CECF09FFE76}" dt="2026-09-23T22:00:49.532" v="285" actId="26606"/>
-          <ac:spMkLst>
-            <pc:docMk/>
-            <pc:sldMk cId="1931892355" sldId="257"/>
-            <ac:spMk id="17" creationId="{3A9A4357-BD1D-4622-A4FE-766E6AB8DE84}"/>
-          </ac:spMkLst>
-        </pc:spChg>
-        <pc:spChg chg="add del">
-          <ac:chgData name="Khalon Rodney" userId="4f27803adad79339" providerId="LiveId" clId="{A02A73CA-AD03-4032-B1B6-1CECF09FFE76}" dt="2026-09-23T22:00:52.011" v="287" actId="26606"/>
-          <ac:spMkLst>
-            <pc:docMk/>
-            <pc:sldMk cId="1931892355" sldId="257"/>
-            <ac:spMk id="19" creationId="{2B97F24A-32CE-4C1C-A50D-3016B394DCFB}"/>
-          </ac:spMkLst>
-        </pc:spChg>
-        <pc:spChg chg="add del">
-          <ac:chgData name="Khalon Rodney" userId="4f27803adad79339" providerId="LiveId" clId="{A02A73CA-AD03-4032-B1B6-1CECF09FFE76}" dt="2026-09-23T22:00:52.011" v="287" actId="26606"/>
-          <ac:spMkLst>
-            <pc:docMk/>
-            <pc:sldMk cId="1931892355" sldId="257"/>
-            <ac:spMk id="20" creationId="{6357EC4F-235E-4222-A36F-C7878ACE37F2}"/>
-          </ac:spMkLst>
-        </pc:spChg>
-        <pc:spChg chg="add del">
-          <ac:chgData name="Khalon Rodney" userId="4f27803adad79339" providerId="LiveId" clId="{A02A73CA-AD03-4032-B1B6-1CECF09FFE76}" dt="2026-09-23T22:00:52.918" v="289" actId="26606"/>
-          <ac:spMkLst>
-            <pc:docMk/>
-            <pc:sldMk cId="1931892355" sldId="257"/>
-            <ac:spMk id="22" creationId="{743AA782-23D1-4521-8CAD-47662984AA08}"/>
-          </ac:spMkLst>
-        </pc:spChg>
-        <pc:spChg chg="add del">
-          <ac:chgData name="Khalon Rodney" userId="4f27803adad79339" providerId="LiveId" clId="{A02A73CA-AD03-4032-B1B6-1CECF09FFE76}" dt="2026-09-23T22:00:52.918" v="289" actId="26606"/>
-          <ac:spMkLst>
-            <pc:docMk/>
-            <pc:sldMk cId="1931892355" sldId="257"/>
-            <ac:spMk id="23" creationId="{71877DBC-BB60-40F0-AC93-2ACDBAAE60CE}"/>
-          </ac:spMkLst>
-        </pc:spChg>
-        <pc:spChg chg="add del">
-          <ac:chgData name="Khalon Rodney" userId="4f27803adad79339" providerId="LiveId" clId="{A02A73CA-AD03-4032-B1B6-1CECF09FFE76}" dt="2026-09-23T22:00:56.970" v="291" actId="26606"/>
-          <ac:spMkLst>
-            <pc:docMk/>
-            <pc:sldMk cId="1931892355" sldId="257"/>
-            <ac:spMk id="25" creationId="{743AA782-23D1-4521-8CAD-47662984AA08}"/>
-          </ac:spMkLst>
-        </pc:spChg>
-        <pc:spChg chg="add del">
-          <ac:chgData name="Khalon Rodney" userId="4f27803adad79339" providerId="LiveId" clId="{A02A73CA-AD03-4032-B1B6-1CECF09FFE76}" dt="2026-09-23T22:00:56.970" v="291" actId="26606"/>
-          <ac:spMkLst>
-            <pc:docMk/>
-            <pc:sldMk cId="1931892355" sldId="257"/>
-            <ac:spMk id="26" creationId="{650D18FE-0824-4A46-B22C-A86B52E5780A}"/>
-          </ac:spMkLst>
-        </pc:spChg>
-        <pc:spChg chg="add del">
-          <ac:chgData name="Khalon Rodney" userId="4f27803adad79339" providerId="LiveId" clId="{A02A73CA-AD03-4032-B1B6-1CECF09FFE76}" dt="2026-09-23T22:01:00.892" v="293" actId="26606"/>
-          <ac:spMkLst>
-            <pc:docMk/>
-            <pc:sldMk cId="1931892355" sldId="257"/>
-            <ac:spMk id="28" creationId="{B6FACB3C-9069-4791-BC5C-0DB7CD19B853}"/>
-          </ac:spMkLst>
-        </pc:spChg>
-        <pc:spChg chg="add del">
-          <ac:chgData name="Khalon Rodney" userId="4f27803adad79339" providerId="LiveId" clId="{A02A73CA-AD03-4032-B1B6-1CECF09FFE76}" dt="2026-09-23T22:01:00.892" v="293" actId="26606"/>
-          <ac:spMkLst>
-            <pc:docMk/>
-            <pc:sldMk cId="1931892355" sldId="257"/>
-            <ac:spMk id="29" creationId="{71F2038E-D777-4B76-81DD-DD13EE91B9DD}"/>
-          </ac:spMkLst>
-        </pc:spChg>
-        <pc:spChg chg="add">
-          <ac:chgData name="Khalon Rodney" userId="4f27803adad79339" providerId="LiveId" clId="{A02A73CA-AD03-4032-B1B6-1CECF09FFE76}" dt="2026-09-23T22:01:00.897" v="294" actId="26606"/>
+          <ac:chgData name="Khalon Rodney" userId="4f27803adad79339" providerId="LiveId" clId="{A02A73CA-AD03-4032-B1B6-1CECF09FFE76}" dt="2026-09-25T03:14:25.906" v="1743" actId="26606"/>
           <ac:spMkLst>
             <pc:docMk/>
             <pc:sldMk cId="1931892355" sldId="257"/>
             <ac:spMk id="35" creationId="{743AA782-23D1-4521-8CAD-47662984AA08}"/>
           </ac:spMkLst>
         </pc:spChg>
-        <pc:spChg chg="add">
-          <ac:chgData name="Khalon Rodney" userId="4f27803adad79339" providerId="LiveId" clId="{A02A73CA-AD03-4032-B1B6-1CECF09FFE76}" dt="2026-09-23T22:01:00.897" v="294" actId="26606"/>
+        <pc:spChg chg="add del">
+          <ac:chgData name="Khalon Rodney" userId="4f27803adad79339" providerId="LiveId" clId="{A02A73CA-AD03-4032-B1B6-1CECF09FFE76}" dt="2026-09-25T03:14:25.906" v="1743" actId="26606"/>
           <ac:spMkLst>
             <pc:docMk/>
             <pc:sldMk cId="1931892355" sldId="257"/>
             <ac:spMk id="36" creationId="{650D18FE-0824-4A46-B22C-A86B52E5780A}"/>
           </ac:spMkLst>
         </pc:spChg>
-        <pc:grpChg chg="add del">
-          <ac:chgData name="Khalon Rodney" userId="4f27803adad79339" providerId="LiveId" clId="{A02A73CA-AD03-4032-B1B6-1CECF09FFE76}" dt="2026-09-23T22:01:00.892" v="293" actId="26606"/>
-          <ac:grpSpMkLst>
+        <pc:spChg chg="add">
+          <ac:chgData name="Khalon Rodney" userId="4f27803adad79339" providerId="LiveId" clId="{A02A73CA-AD03-4032-B1B6-1CECF09FFE76}" dt="2026-09-25T03:14:25.906" v="1743" actId="26606"/>
+          <ac:spMkLst>
             <pc:docMk/>
             <pc:sldMk cId="1931892355" sldId="257"/>
-            <ac:grpSpMk id="30" creationId="{DD354807-230F-4402-B1B9-F733A8F1F190}"/>
-          </ac:grpSpMkLst>
-        </pc:grpChg>
-        <pc:picChg chg="add mod">
-          <ac:chgData name="Khalon Rodney" userId="4f27803adad79339" providerId="LiveId" clId="{A02A73CA-AD03-4032-B1B6-1CECF09FFE76}" dt="2026-09-23T22:01:29.683" v="305" actId="1076"/>
+            <ac:spMk id="42" creationId="{3ECBE1F1-D69B-4AFA-ABD5-8E41720EF6DE}"/>
+          </ac:spMkLst>
+        </pc:spChg>
+        <pc:spChg chg="add">
+          <ac:chgData name="Khalon Rodney" userId="4f27803adad79339" providerId="LiveId" clId="{A02A73CA-AD03-4032-B1B6-1CECF09FFE76}" dt="2026-09-25T03:14:25.906" v="1743" actId="26606"/>
+          <ac:spMkLst>
+            <pc:docMk/>
+            <pc:sldMk cId="1931892355" sldId="257"/>
+            <ac:spMk id="44" creationId="{603A6265-E10C-4B85-9C20-E75FCAF9CC63}"/>
+          </ac:spMkLst>
+        </pc:spChg>
+        <pc:picChg chg="add del mod">
+          <ac:chgData name="Khalon Rodney" userId="4f27803adad79339" providerId="LiveId" clId="{A02A73CA-AD03-4032-B1B6-1CECF09FFE76}" dt="2026-09-25T03:14:17.021" v="1742" actId="478"/>
           <ac:picMkLst>
             <pc:docMk/>
             <pc:sldMk cId="1931892355" sldId="257"/>
             <ac:picMk id="5" creationId="{F7A51163-A173-4C99-0C76-B8371B95C557}"/>
+          </ac:picMkLst>
+        </pc:picChg>
+        <pc:picChg chg="add">
+          <ac:chgData name="Khalon Rodney" userId="4f27803adad79339" providerId="LiveId" clId="{A02A73CA-AD03-4032-B1B6-1CECF09FFE76}" dt="2026-09-25T03:14:25.906" v="1743" actId="26606"/>
+          <ac:picMkLst>
+            <pc:docMk/>
+            <pc:sldMk cId="1931892355" sldId="257"/>
+            <ac:picMk id="38" creationId="{5956CE63-1356-CA76-FFC1-ED6EF1E5F211}"/>
           </ac:picMkLst>
         </pc:picChg>
       </pc:sldChg>
@@ -7517,7 +7436,7 @@
           <a:p>
             <a:fld id="{F0E4DEF5-8833-4B8D-B0EC-67BD3EB23315}" type="datetimeFigureOut">
               <a:rPr lang="en-US" smtClean="0"/>
-              <a:t>9/23/2026</a:t>
+              <a:t>9/24/2026</a:t>
             </a:fld>
             <a:endParaRPr lang="en-US"/>
           </a:p>
@@ -7715,7 +7634,7 @@
           <a:p>
             <a:fld id="{F0E4DEF5-8833-4B8D-B0EC-67BD3EB23315}" type="datetimeFigureOut">
               <a:rPr lang="en-US" smtClean="0"/>
-              <a:t>9/23/2026</a:t>
+              <a:t>9/24/2026</a:t>
             </a:fld>
             <a:endParaRPr lang="en-US"/>
           </a:p>
@@ -7923,7 +7842,7 @@
           <a:p>
             <a:fld id="{F0E4DEF5-8833-4B8D-B0EC-67BD3EB23315}" type="datetimeFigureOut">
               <a:rPr lang="en-US" smtClean="0"/>
-              <a:t>9/23/2026</a:t>
+              <a:t>9/24/2026</a:t>
             </a:fld>
             <a:endParaRPr lang="en-US"/>
           </a:p>
@@ -8120,7 +8039,7 @@
             <a:fld id="{EEE2A7A0-B9EE-41A8-8016-28E5803F20B2}" type="datetime1">
               <a:rPr lang="en-US" smtClean="0"/>
               <a:pPr/>
-              <a:t>9/23/2026</a:t>
+              <a:t>9/24/2026</a:t>
             </a:fld>
             <a:endParaRPr lang="en-US"/>
           </a:p>
@@ -8307,7 +8226,7 @@
           <a:p>
             <a:fld id="{F0E4DEF5-8833-4B8D-B0EC-67BD3EB23315}" type="datetimeFigureOut">
               <a:rPr lang="en-US" smtClean="0"/>
-              <a:t>9/23/2026</a:t>
+              <a:t>9/24/2026</a:t>
             </a:fld>
             <a:endParaRPr lang="en-US"/>
           </a:p>
@@ -8582,7 +8501,7 @@
           <a:p>
             <a:fld id="{F0E4DEF5-8833-4B8D-B0EC-67BD3EB23315}" type="datetimeFigureOut">
               <a:rPr lang="en-US" smtClean="0"/>
-              <a:t>9/23/2026</a:t>
+              <a:t>9/24/2026</a:t>
             </a:fld>
             <a:endParaRPr lang="en-US"/>
           </a:p>
@@ -8847,7 +8766,7 @@
           <a:p>
             <a:fld id="{F0E4DEF5-8833-4B8D-B0EC-67BD3EB23315}" type="datetimeFigureOut">
               <a:rPr lang="en-US" smtClean="0"/>
-              <a:t>9/23/2026</a:t>
+              <a:t>9/24/2026</a:t>
             </a:fld>
             <a:endParaRPr lang="en-US"/>
           </a:p>
@@ -9259,7 +9178,7 @@
           <a:p>
             <a:fld id="{F0E4DEF5-8833-4B8D-B0EC-67BD3EB23315}" type="datetimeFigureOut">
               <a:rPr lang="en-US" smtClean="0"/>
-              <a:t>9/23/2026</a:t>
+              <a:t>9/24/2026</a:t>
             </a:fld>
             <a:endParaRPr lang="en-US"/>
           </a:p>
@@ -9400,7 +9319,7 @@
           <a:p>
             <a:fld id="{F0E4DEF5-8833-4B8D-B0EC-67BD3EB23315}" type="datetimeFigureOut">
               <a:rPr lang="en-US" smtClean="0"/>
-              <a:t>9/23/2026</a:t>
+              <a:t>9/24/2026</a:t>
             </a:fld>
             <a:endParaRPr lang="en-US"/>
           </a:p>
@@ -9513,7 +9432,7 @@
           <a:p>
             <a:fld id="{F0E4DEF5-8833-4B8D-B0EC-67BD3EB23315}" type="datetimeFigureOut">
               <a:rPr lang="en-US" smtClean="0"/>
-              <a:t>9/23/2026</a:t>
+              <a:t>9/24/2026</a:t>
             </a:fld>
             <a:endParaRPr lang="en-US"/>
           </a:p>
@@ -9824,7 +9743,7 @@
           <a:p>
             <a:fld id="{F0E4DEF5-8833-4B8D-B0EC-67BD3EB23315}" type="datetimeFigureOut">
               <a:rPr lang="en-US" smtClean="0"/>
-              <a:t>9/23/2026</a:t>
+              <a:t>9/24/2026</a:t>
             </a:fld>
             <a:endParaRPr lang="en-US"/>
           </a:p>
@@ -10112,7 +10031,7 @@
           <a:p>
             <a:fld id="{F0E4DEF5-8833-4B8D-B0EC-67BD3EB23315}" type="datetimeFigureOut">
               <a:rPr lang="en-US" smtClean="0"/>
-              <a:t>9/23/2026</a:t>
+              <a:t>9/24/2026</a:t>
             </a:fld>
             <a:endParaRPr lang="en-US"/>
           </a:p>
@@ -10353,7 +10272,7 @@
           <a:p>
             <a:fld id="{F0E4DEF5-8833-4B8D-B0EC-67BD3EB23315}" type="datetimeFigureOut">
               <a:rPr lang="en-US" smtClean="0"/>
-              <a:t>9/23/2026</a:t>
+              <a:t>9/24/2026</a:t>
             </a:fld>
             <a:endParaRPr lang="en-US"/>
           </a:p>
@@ -11002,7 +10921,7 @@
           <a:lstStyle/>
           <a:p>
             <a:r>
-              <a:rPr lang="en-US" sz="8100" kern="1200">
+              <a:rPr lang="en-US" sz="8100" kern="1200" dirty="0">
                 <a:solidFill>
                   <a:schemeClr val="tx1"/>
                 </a:solidFill>
@@ -11010,7 +10929,7 @@
                 <a:ea typeface="+mj-ea"/>
                 <a:cs typeface="+mj-cs"/>
               </a:rPr>
-              <a:t>3-Tier Console Based Banking Application</a:t>
+              <a:t>Project 1- Banking Application</a:t>
             </a:r>
           </a:p>
         </p:txBody>
@@ -11196,10 +11115,10 @@
       </p:grpSpPr>
       <p:sp useBgFill="1">
         <p:nvSpPr>
-          <p:cNvPr id="35" name="Rectangle 34">
+          <p:cNvPr id="42" name="Slide Background">
             <a:extLst>
               <a:ext uri="{FF2B5EF4-FFF2-40B4-BE49-F238E27FC236}">
-                <a16:creationId xmlns:a16="http://schemas.microsoft.com/office/drawing/2014/main" id="{743AA782-23D1-4521-8CAD-47662984AA08}"/>
+                <a16:creationId xmlns:a16="http://schemas.microsoft.com/office/drawing/2014/main" id="{3ECBE1F1-D69B-4AFA-ABD5-8E41720EF6DE}"/>
               </a:ext>
               <a:ext uri="{C183D7F6-B498-43B3-948B-1728B52AA6E4}">
                 <adec:decorative xmlns:adec="http://schemas.microsoft.com/office/drawing/2017/decorative" val="1"/>
@@ -11254,54 +11173,43 @@
           </a:p>
         </p:txBody>
       </p:sp>
-      <p:sp>
-        <p:nvSpPr>
-          <p:cNvPr id="2" name="Title 1">
+      <p:pic>
+        <p:nvPicPr>
+          <p:cNvPr id="38" name="Picture 37">
             <a:extLst>
               <a:ext uri="{FF2B5EF4-FFF2-40B4-BE49-F238E27FC236}">
-                <a16:creationId xmlns:a16="http://schemas.microsoft.com/office/drawing/2014/main" id="{3F1B8872-421E-808B-7C4D-E1701F257102}"/>
+                <a16:creationId xmlns:a16="http://schemas.microsoft.com/office/drawing/2014/main" id="{5956CE63-1356-CA76-FFC1-ED6EF1E5F211}"/>
               </a:ext>
             </a:extLst>
           </p:cNvPr>
-          <p:cNvSpPr>
-            <a:spLocks noGrp="1"/>
-          </p:cNvSpPr>
-          <p:nvPr>
-            <p:ph type="title"/>
-          </p:nvPr>
-        </p:nvSpPr>
+          <p:cNvPicPr>
+            <a:picLocks noChangeAspect="1"/>
+          </p:cNvPicPr>
+          <p:nvPr/>
+        </p:nvPicPr>
+        <p:blipFill>
+          <a:blip r:embed="rId2"/>
+          <a:srcRect l="11248" r="44377"/>
+          <a:stretch>
+            <a:fillRect/>
+          </a:stretch>
+        </p:blipFill>
         <p:spPr>
           <a:xfrm>
-            <a:off x="630936" y="640080"/>
-            <a:ext cx="4818888" cy="1481328"/>
+            <a:off x="-1" y="-2"/>
+            <a:ext cx="5410198" cy="6858002"/>
           </a:xfrm>
+          <a:prstGeom prst="rect">
+            <a:avLst/>
+          </a:prstGeom>
         </p:spPr>
-        <p:txBody>
-          <a:bodyPr vert="horz" lIns="91440" tIns="45720" rIns="91440" bIns="45720" rtlCol="0" anchor="b">
-            <a:normAutofit/>
-          </a:bodyPr>
-          <a:lstStyle/>
-          <a:p>
-            <a:r>
-              <a:rPr lang="en-US" sz="5000" kern="1200" dirty="0">
-                <a:solidFill>
-                  <a:schemeClr val="tx1"/>
-                </a:solidFill>
-                <a:latin typeface="+mj-lt"/>
-                <a:ea typeface="+mj-ea"/>
-                <a:cs typeface="+mj-cs"/>
-              </a:rPr>
-              <a:t>Project Overview</a:t>
-            </a:r>
-          </a:p>
-        </p:txBody>
-      </p:sp>
-      <p:sp>
+      </p:pic>
+      <p:sp useBgFill="1">
         <p:nvSpPr>
-          <p:cNvPr id="36" name="sketch line">
+          <p:cNvPr id="44" name="Rectangle 43">
             <a:extLst>
               <a:ext uri="{FF2B5EF4-FFF2-40B4-BE49-F238E27FC236}">
-                <a16:creationId xmlns:a16="http://schemas.microsoft.com/office/drawing/2014/main" id="{650D18FE-0824-4A46-B22C-A86B52E5780A}"/>
+                <a16:creationId xmlns:a16="http://schemas.microsoft.com/office/drawing/2014/main" id="{603A6265-E10C-4B85-9C20-E75FCAF9CC63}"/>
               </a:ext>
               <a:ext uri="{C183D7F6-B498-43B3-948B-1728B52AA6E4}">
                 <adec:decorative xmlns:adec="http://schemas.microsoft.com/office/drawing/2017/decorative" val="1"/>
@@ -11321,228 +11229,22 @@
         </p:nvSpPr>
         <p:spPr>
           <a:xfrm>
-            <a:off x="643278" y="2372868"/>
-            <a:ext cx="3255095" cy="18288"/>
+            <a:off x="5410197" y="-1"/>
+            <a:ext cx="6781802" cy="2286000"/>
           </a:xfrm>
-          <a:custGeom>
+          <a:prstGeom prst="rect">
             <a:avLst/>
-            <a:gdLst>
-              <a:gd name="csX0" fmla="*/ 0 w 3255095"/>
-              <a:gd name="csY0" fmla="*/ 0 h 18288"/>
-              <a:gd name="csX1" fmla="*/ 618468 w 3255095"/>
-              <a:gd name="csY1" fmla="*/ 0 h 18288"/>
-              <a:gd name="csX2" fmla="*/ 1269487 w 3255095"/>
-              <a:gd name="csY2" fmla="*/ 0 h 18288"/>
-              <a:gd name="csX3" fmla="*/ 1953057 w 3255095"/>
-              <a:gd name="csY3" fmla="*/ 0 h 18288"/>
-              <a:gd name="csX4" fmla="*/ 2636627 w 3255095"/>
-              <a:gd name="csY4" fmla="*/ 0 h 18288"/>
-              <a:gd name="csX5" fmla="*/ 3255095 w 3255095"/>
-              <a:gd name="csY5" fmla="*/ 0 h 18288"/>
-              <a:gd name="csX6" fmla="*/ 3255095 w 3255095"/>
-              <a:gd name="csY6" fmla="*/ 18288 h 18288"/>
-              <a:gd name="csX7" fmla="*/ 2538974 w 3255095"/>
-              <a:gd name="csY7" fmla="*/ 18288 h 18288"/>
-              <a:gd name="csX8" fmla="*/ 1822853 w 3255095"/>
-              <a:gd name="csY8" fmla="*/ 18288 h 18288"/>
-              <a:gd name="csX9" fmla="*/ 1171834 w 3255095"/>
-              <a:gd name="csY9" fmla="*/ 18288 h 18288"/>
-              <a:gd name="csX10" fmla="*/ 0 w 3255095"/>
-              <a:gd name="csY10" fmla="*/ 18288 h 18288"/>
-              <a:gd name="csX11" fmla="*/ 0 w 3255095"/>
-              <a:gd name="csY11" fmla="*/ 0 h 18288"/>
-            </a:gdLst>
-            <a:ahLst/>
-            <a:cxnLst>
-              <a:cxn ang="0">
-                <a:pos x="csX0" y="csY0"/>
-              </a:cxn>
-              <a:cxn ang="0">
-                <a:pos x="csX1" y="csY1"/>
-              </a:cxn>
-              <a:cxn ang="0">
-                <a:pos x="csX2" y="csY2"/>
-              </a:cxn>
-              <a:cxn ang="0">
-                <a:pos x="csX3" y="csY3"/>
-              </a:cxn>
-              <a:cxn ang="0">
-                <a:pos x="csX4" y="csY4"/>
-              </a:cxn>
-              <a:cxn ang="0">
-                <a:pos x="csX5" y="csY5"/>
-              </a:cxn>
-              <a:cxn ang="0">
-                <a:pos x="csX6" y="csY6"/>
-              </a:cxn>
-              <a:cxn ang="0">
-                <a:pos x="csX7" y="csY7"/>
-              </a:cxn>
-              <a:cxn ang="0">
-                <a:pos x="csX8" y="csY8"/>
-              </a:cxn>
-              <a:cxn ang="0">
-                <a:pos x="csX9" y="csY9"/>
-              </a:cxn>
-              <a:cxn ang="0">
-                <a:pos x="csX10" y="csY10"/>
-              </a:cxn>
-              <a:cxn ang="0">
-                <a:pos x="csX11" y="csY11"/>
-              </a:cxn>
-            </a:cxnLst>
-            <a:rect l="l" t="t" r="r" b="b"/>
-            <a:pathLst>
-              <a:path w="3255095" h="18288" fill="none" extrusionOk="0">
-                <a:moveTo>
-                  <a:pt x="0" y="0"/>
-                </a:moveTo>
-                <a:cubicBezTo>
-                  <a:pt x="240201" y="-22123"/>
-                  <a:pt x="462021" y="-19623"/>
-                  <a:pt x="618468" y="0"/>
-                </a:cubicBezTo>
-                <a:cubicBezTo>
-                  <a:pt x="774915" y="19623"/>
-                  <a:pt x="974734" y="2035"/>
-                  <a:pt x="1269487" y="0"/>
-                </a:cubicBezTo>
-                <a:cubicBezTo>
-                  <a:pt x="1564240" y="-2035"/>
-                  <a:pt x="1733579" y="10639"/>
-                  <a:pt x="1953057" y="0"/>
-                </a:cubicBezTo>
-                <a:cubicBezTo>
-                  <a:pt x="2172535" y="-10639"/>
-                  <a:pt x="2453962" y="14018"/>
-                  <a:pt x="2636627" y="0"/>
-                </a:cubicBezTo>
-                <a:cubicBezTo>
-                  <a:pt x="2819292" y="-14018"/>
-                  <a:pt x="3121375" y="5399"/>
-                  <a:pt x="3255095" y="0"/>
-                </a:cubicBezTo>
-                <a:cubicBezTo>
-                  <a:pt x="3254386" y="8157"/>
-                  <a:pt x="3254682" y="12125"/>
-                  <a:pt x="3255095" y="18288"/>
-                </a:cubicBezTo>
-                <a:cubicBezTo>
-                  <a:pt x="3088545" y="23203"/>
-                  <a:pt x="2687475" y="7419"/>
-                  <a:pt x="2538974" y="18288"/>
-                </a:cubicBezTo>
-                <a:cubicBezTo>
-                  <a:pt x="2390473" y="29157"/>
-                  <a:pt x="2137381" y="-8959"/>
-                  <a:pt x="1822853" y="18288"/>
-                </a:cubicBezTo>
-                <a:cubicBezTo>
-                  <a:pt x="1508325" y="45535"/>
-                  <a:pt x="1466437" y="20385"/>
-                  <a:pt x="1171834" y="18288"/>
-                </a:cubicBezTo>
-                <a:cubicBezTo>
-                  <a:pt x="877231" y="16191"/>
-                  <a:pt x="561097" y="37643"/>
-                  <a:pt x="0" y="18288"/>
-                </a:cubicBezTo>
-                <a:cubicBezTo>
-                  <a:pt x="-46" y="12483"/>
-                  <a:pt x="-203" y="6491"/>
-                  <a:pt x="0" y="0"/>
-                </a:cubicBezTo>
-                <a:close/>
-              </a:path>
-              <a:path w="3255095" h="18288" stroke="0" extrusionOk="0">
-                <a:moveTo>
-                  <a:pt x="0" y="0"/>
-                </a:moveTo>
-                <a:cubicBezTo>
-                  <a:pt x="291965" y="19429"/>
-                  <a:pt x="363155" y="8568"/>
-                  <a:pt x="618468" y="0"/>
-                </a:cubicBezTo>
-                <a:cubicBezTo>
-                  <a:pt x="873781" y="-8568"/>
-                  <a:pt x="904459" y="-19505"/>
-                  <a:pt x="1171834" y="0"/>
-                </a:cubicBezTo>
-                <a:cubicBezTo>
-                  <a:pt x="1439209" y="19505"/>
-                  <a:pt x="1744369" y="9790"/>
-                  <a:pt x="1887955" y="0"/>
-                </a:cubicBezTo>
-                <a:cubicBezTo>
-                  <a:pt x="2031541" y="-9790"/>
-                  <a:pt x="2346378" y="21240"/>
-                  <a:pt x="2506423" y="0"/>
-                </a:cubicBezTo>
-                <a:cubicBezTo>
-                  <a:pt x="2666468" y="-21240"/>
-                  <a:pt x="2990257" y="30414"/>
-                  <a:pt x="3255095" y="0"/>
-                </a:cubicBezTo>
-                <a:cubicBezTo>
-                  <a:pt x="3254831" y="4493"/>
-                  <a:pt x="3255479" y="9472"/>
-                  <a:pt x="3255095" y="18288"/>
-                </a:cubicBezTo>
-                <a:cubicBezTo>
-                  <a:pt x="3120743" y="16690"/>
-                  <a:pt x="2759628" y="42462"/>
-                  <a:pt x="2604076" y="18288"/>
-                </a:cubicBezTo>
-                <a:cubicBezTo>
-                  <a:pt x="2448524" y="-5886"/>
-                  <a:pt x="2184336" y="19599"/>
-                  <a:pt x="1887955" y="18288"/>
-                </a:cubicBezTo>
-                <a:cubicBezTo>
-                  <a:pt x="1591574" y="16977"/>
-                  <a:pt x="1548845" y="6870"/>
-                  <a:pt x="1334589" y="18288"/>
-                </a:cubicBezTo>
-                <a:cubicBezTo>
-                  <a:pt x="1120333" y="29706"/>
-                  <a:pt x="996014" y="9662"/>
-                  <a:pt x="683570" y="18288"/>
-                </a:cubicBezTo>
-                <a:cubicBezTo>
-                  <a:pt x="371126" y="26914"/>
-                  <a:pt x="198687" y="16167"/>
-                  <a:pt x="0" y="18288"/>
-                </a:cubicBezTo>
-                <a:cubicBezTo>
-                  <a:pt x="843" y="9577"/>
-                  <a:pt x="371" y="6900"/>
-                  <a:pt x="0" y="0"/>
-                </a:cubicBezTo>
-                <a:close/>
-              </a:path>
-            </a:pathLst>
-          </a:custGeom>
-          <a:solidFill>
-            <a:schemeClr val="accent2"/>
-          </a:solidFill>
-          <a:ln w="38100" cap="rnd">
-            <a:solidFill>
-              <a:schemeClr val="accent2"/>
-            </a:solidFill>
-            <a:round/>
-            <a:extLst>
-              <a:ext uri="{C807C97D-BFC1-408E-A445-0C87EB9F89A2}">
-                <ask:lineSketchStyleProps xmlns:ask="http://schemas.microsoft.com/office/drawing/2018/sketchyshapes" sd="1219033472">
-                  <a:prstGeom prst="rect">
-                    <a:avLst/>
-                  </a:prstGeom>
-                  <ask:type>
-                    <ask:lineSketchFreehand/>
-                  </ask:type>
-                </ask:lineSketchStyleProps>
-              </a:ext>
-            </a:extLst>
+          </a:prstGeom>
+          <a:ln>
+            <a:noFill/>
           </a:ln>
+          <a:effectLst>
+            <a:outerShdw blurRad="355600" dist="152400" sx="95000" sy="95000" algn="t" rotWithShape="0">
+              <a:srgbClr val="000000">
+                <a:alpha val="29000"/>
+              </a:srgbClr>
+            </a:outerShdw>
+          </a:effectLst>
         </p:spPr>
         <p:style>
           <a:lnRef idx="2">
@@ -11571,6 +11273,41 @@
       </p:sp>
       <p:sp>
         <p:nvSpPr>
+          <p:cNvPr id="2" name="Title 1">
+            <a:extLst>
+              <a:ext uri="{FF2B5EF4-FFF2-40B4-BE49-F238E27FC236}">
+                <a16:creationId xmlns:a16="http://schemas.microsoft.com/office/drawing/2014/main" id="{3F1B8872-421E-808B-7C4D-E1701F257102}"/>
+              </a:ext>
+            </a:extLst>
+          </p:cNvPr>
+          <p:cNvSpPr>
+            <a:spLocks noGrp="1"/>
+          </p:cNvSpPr>
+          <p:nvPr>
+            <p:ph type="title"/>
+          </p:nvPr>
+        </p:nvSpPr>
+        <p:spPr>
+          <a:xfrm>
+            <a:off x="6115317" y="405685"/>
+            <a:ext cx="5464968" cy="1559301"/>
+          </a:xfrm>
+        </p:spPr>
+        <p:txBody>
+          <a:bodyPr vert="horz" lIns="91440" tIns="45720" rIns="91440" bIns="45720" rtlCol="0" anchor="ctr">
+            <a:normAutofit/>
+          </a:bodyPr>
+          <a:lstStyle/>
+          <a:p>
+            <a:r>
+              <a:rPr lang="en-US" sz="4000"/>
+              <a:t>Project Overview</a:t>
+            </a:r>
+          </a:p>
+        </p:txBody>
+      </p:sp>
+      <p:sp>
+        <p:nvSpPr>
           <p:cNvPr id="3" name="TextBox 2">
             <a:extLst>
               <a:ext uri="{FF2B5EF4-FFF2-40B4-BE49-F238E27FC236}">
@@ -11583,22 +11320,22 @@
         </p:nvSpPr>
         <p:spPr>
           <a:xfrm>
-            <a:off x="107290" y="2391156"/>
-            <a:ext cx="6344716" cy="4466844"/>
+            <a:off x="5410197" y="2285999"/>
+            <a:ext cx="6838510" cy="4572001"/>
           </a:xfrm>
           <a:prstGeom prst="rect">
             <a:avLst/>
           </a:prstGeom>
         </p:spPr>
         <p:txBody>
-          <a:bodyPr vert="horz" lIns="91440" tIns="45720" rIns="91440" bIns="45720" rtlCol="0" anchor="t">
-            <a:noAutofit/>
+          <a:bodyPr vert="horz" lIns="91440" tIns="45720" rIns="91440" bIns="45720" rtlCol="0" anchor="ctr">
+            <a:normAutofit/>
           </a:bodyPr>
           <a:lstStyle/>
           <a:p>
             <a:pPr indent="-228600">
               <a:lnSpc>
-                <a:spcPct val="150000"/>
+                <a:spcPct val="90000"/>
               </a:lnSpc>
               <a:spcAft>
                 <a:spcPts val="600"/>
@@ -11608,13 +11345,13 @@
             </a:pPr>
             <a:r>
               <a:rPr lang="en-US" sz="2000" dirty="0"/>
-              <a:t>A fully functional banking console application built using object-oriented design and a real relational database. Designed to simulate banking operations for customers and admins.</a:t>
+              <a:t>A fully functional 3-tier architecture banking console application built using object-oriented design and a real relational database. Designed to simulate banking operations for customers and admins.</a:t>
             </a:r>
           </a:p>
           <a:p>
             <a:pPr marL="914400" lvl="1" indent="-228600">
               <a:lnSpc>
-                <a:spcPct val="150000"/>
+                <a:spcPct val="90000"/>
               </a:lnSpc>
               <a:spcAft>
                 <a:spcPts val="600"/>
@@ -11630,7 +11367,7 @@
           <a:p>
             <a:pPr marL="914400" lvl="1" indent="-228600">
               <a:lnSpc>
-                <a:spcPct val="150000"/>
+                <a:spcPct val="90000"/>
               </a:lnSpc>
               <a:spcAft>
                 <a:spcPts val="600"/>
@@ -11646,7 +11383,7 @@
           <a:p>
             <a:pPr marL="914400" lvl="1" indent="-228600">
               <a:lnSpc>
-                <a:spcPct val="150000"/>
+                <a:spcPct val="90000"/>
               </a:lnSpc>
               <a:spcAft>
                 <a:spcPts val="600"/>
@@ -11662,7 +11399,7 @@
           <a:p>
             <a:pPr marL="914400" lvl="1" indent="-228600">
               <a:lnSpc>
-                <a:spcPct val="150000"/>
+                <a:spcPct val="90000"/>
               </a:lnSpc>
               <a:spcAft>
                 <a:spcPts val="600"/>
@@ -11703,36 +11440,6 @@
           </a:p>
         </p:txBody>
       </p:sp>
-      <p:pic>
-        <p:nvPicPr>
-          <p:cNvPr id="5" name="Picture 4">
-            <a:extLst>
-              <a:ext uri="{FF2B5EF4-FFF2-40B4-BE49-F238E27FC236}">
-                <a16:creationId xmlns:a16="http://schemas.microsoft.com/office/drawing/2014/main" id="{F7A51163-A173-4C99-0C76-B8371B95C557}"/>
-              </a:ext>
-            </a:extLst>
-          </p:cNvPr>
-          <p:cNvPicPr>
-            <a:picLocks noChangeAspect="1"/>
-          </p:cNvPicPr>
-          <p:nvPr/>
-        </p:nvPicPr>
-        <p:blipFill>
-          <a:blip r:embed="rId2"/>
-          <a:stretch>
-            <a:fillRect/>
-          </a:stretch>
-        </p:blipFill>
-        <p:spPr>
-          <a:xfrm>
-            <a:off x="6625742" y="1742418"/>
-            <a:ext cx="5458968" cy="3197599"/>
-          </a:xfrm>
-          <a:prstGeom prst="rect">
-            <a:avLst/>
-          </a:prstGeom>
-        </p:spPr>
-      </p:pic>
     </p:spTree>
     <p:extLst>
       <p:ext uri="{BB962C8B-B14F-4D97-AF65-F5344CB8AC3E}">

</xml_diff>